<commit_message>
Add editable debug evidence label to V2 poster
Co-authored-by: Shyam <shyam.nexus@gmail.com>
</commit_message>
<xml_diff>
--- a/Coding Embedded Workstream - Common Idea Poster V2.pptx
+++ b/Coding Embedded Workstream - Common Idea Poster V2.pptx
@@ -6097,6 +6097,41 @@
                 <a:latin typeface="Arial"/>
               </a:rPr>
               <a:t>SoC / MCU | PCB traces | JTAG/SWD | ROVO Studio | Copilot | Atlassian MCP | GitHub | Jira | Confluence</a:t>
+            </a:r>
+          </a:p>
+        </p:txBody>
+      </p:sp>
+      <p:sp>
+        <p:nvSpPr>
+          <p:cNvPr id="82" name="TextBox 81"/>
+          <p:cNvSpPr txBox="1"/>
+          <p:nvPr/>
+        </p:nvSpPr>
+        <p:spPr>
+          <a:xfrm>
+            <a:off x="5925312" y="3858768"/>
+            <a:ext cx="2926080" cy="164592"/>
+          </a:xfrm>
+          <a:prstGeom prst="rect">
+            <a:avLst/>
+          </a:prstGeom>
+          <a:noFill/>
+        </p:spPr>
+        <p:txBody>
+          <a:bodyPr wrap="none">
+            <a:spAutoFit/>
+          </a:bodyPr>
+          <a:lstStyle/>
+          <a:p>
+            <a:pPr algn="l"/>
+            <a:r>
+              <a:rPr sz="850" b="1">
+                <a:solidFill>
+                  <a:srgbClr val="D71920"/>
+                </a:solidFill>
+                <a:latin typeface="Arial"/>
+              </a:rPr>
+              <a:t>DEBUG SIGNALS + REGISTER EVIDENCE</a:t>
             </a:r>
           </a:p>
         </p:txBody>

</xml_diff>